<commit_message>
Update & Add new ppts
</commit_message>
<xml_diff>
--- a/中越詩歌/平安的路_Con đường bình an.pptx
+++ b/中越詩歌/平安的路_Con đường bình an.pptx
@@ -163,7 +163,7 @@
           <a:lstStyle/>
           <a:p>
             <a:r>
-              <a:rPr lang="en-US" altLang="zh-TW" smtClean="0"/>
+              <a:rPr lang="en-US" altLang="zh-TW"/>
               <a:t>Click to edit Master title style</a:t>
             </a:r>
             <a:endParaRPr lang="zh-TW" altLang="en-US"/>
@@ -282,7 +282,7 @@
           </a:lstStyle>
           <a:p>
             <a:r>
-              <a:rPr lang="en-US" altLang="zh-TW" smtClean="0"/>
+              <a:rPr lang="en-US" altLang="zh-TW"/>
               <a:t>Click to edit Master subtitle style</a:t>
             </a:r>
             <a:endParaRPr lang="zh-TW" altLang="en-US"/>
@@ -306,7 +306,7 @@
           <a:p>
             <a:fld id="{4708DAAA-A60A-4649-A77A-7F12CC5C96A6}" type="datetimeFigureOut">
               <a:rPr lang="vi-VN" smtClean="0"/>
-              <a:t>03/08/2022</a:t>
+              <a:t>03/08/2024</a:t>
             </a:fld>
             <a:endParaRPr lang="vi-VN"/>
           </a:p>
@@ -400,7 +400,7 @@
           <a:lstStyle/>
           <a:p>
             <a:r>
-              <a:rPr lang="en-US" altLang="zh-TW" smtClean="0"/>
+              <a:rPr lang="en-US" altLang="zh-TW"/>
               <a:t>Click to edit Master title style</a:t>
             </a:r>
             <a:endParaRPr lang="zh-TW" altLang="en-US"/>
@@ -424,35 +424,35 @@
           <a:p>
             <a:pPr lvl="0"/>
             <a:r>
-              <a:rPr lang="en-US" altLang="zh-TW" smtClean="0"/>
+              <a:rPr lang="en-US" altLang="zh-TW"/>
               <a:t>Edit Master text styles</a:t>
             </a:r>
           </a:p>
           <a:p>
             <a:pPr lvl="1"/>
             <a:r>
-              <a:rPr lang="en-US" altLang="zh-TW" smtClean="0"/>
+              <a:rPr lang="en-US" altLang="zh-TW"/>
               <a:t>Second level</a:t>
             </a:r>
           </a:p>
           <a:p>
             <a:pPr lvl="2"/>
             <a:r>
-              <a:rPr lang="en-US" altLang="zh-TW" smtClean="0"/>
+              <a:rPr lang="en-US" altLang="zh-TW"/>
               <a:t>Third level</a:t>
             </a:r>
           </a:p>
           <a:p>
             <a:pPr lvl="3"/>
             <a:r>
-              <a:rPr lang="en-US" altLang="zh-TW" smtClean="0"/>
+              <a:rPr lang="en-US" altLang="zh-TW"/>
               <a:t>Fourth level</a:t>
             </a:r>
           </a:p>
           <a:p>
             <a:pPr lvl="4"/>
             <a:r>
-              <a:rPr lang="en-US" altLang="zh-TW" smtClean="0"/>
+              <a:rPr lang="en-US" altLang="zh-TW"/>
               <a:t>Fifth level</a:t>
             </a:r>
             <a:endParaRPr lang="zh-TW" altLang="en-US"/>
@@ -476,7 +476,7 @@
           <a:p>
             <a:fld id="{4708DAAA-A60A-4649-A77A-7F12CC5C96A6}" type="datetimeFigureOut">
               <a:rPr lang="vi-VN" smtClean="0"/>
-              <a:t>03/08/2022</a:t>
+              <a:t>03/08/2024</a:t>
             </a:fld>
             <a:endParaRPr lang="vi-VN"/>
           </a:p>
@@ -575,7 +575,7 @@
           <a:lstStyle/>
           <a:p>
             <a:r>
-              <a:rPr lang="en-US" altLang="zh-TW" smtClean="0"/>
+              <a:rPr lang="en-US" altLang="zh-TW"/>
               <a:t>Click to edit Master title style</a:t>
             </a:r>
             <a:endParaRPr lang="zh-TW" altLang="en-US"/>
@@ -604,35 +604,35 @@
           <a:p>
             <a:pPr lvl="0"/>
             <a:r>
-              <a:rPr lang="en-US" altLang="zh-TW" smtClean="0"/>
+              <a:rPr lang="en-US" altLang="zh-TW"/>
               <a:t>Edit Master text styles</a:t>
             </a:r>
           </a:p>
           <a:p>
             <a:pPr lvl="1"/>
             <a:r>
-              <a:rPr lang="en-US" altLang="zh-TW" smtClean="0"/>
+              <a:rPr lang="en-US" altLang="zh-TW"/>
               <a:t>Second level</a:t>
             </a:r>
           </a:p>
           <a:p>
             <a:pPr lvl="2"/>
             <a:r>
-              <a:rPr lang="en-US" altLang="zh-TW" smtClean="0"/>
+              <a:rPr lang="en-US" altLang="zh-TW"/>
               <a:t>Third level</a:t>
             </a:r>
           </a:p>
           <a:p>
             <a:pPr lvl="3"/>
             <a:r>
-              <a:rPr lang="en-US" altLang="zh-TW" smtClean="0"/>
+              <a:rPr lang="en-US" altLang="zh-TW"/>
               <a:t>Fourth level</a:t>
             </a:r>
           </a:p>
           <a:p>
             <a:pPr lvl="4"/>
             <a:r>
-              <a:rPr lang="en-US" altLang="zh-TW" smtClean="0"/>
+              <a:rPr lang="en-US" altLang="zh-TW"/>
               <a:t>Fifth level</a:t>
             </a:r>
             <a:endParaRPr lang="zh-TW" altLang="en-US"/>
@@ -656,7 +656,7 @@
           <a:p>
             <a:fld id="{4708DAAA-A60A-4649-A77A-7F12CC5C96A6}" type="datetimeFigureOut">
               <a:rPr lang="vi-VN" smtClean="0"/>
-              <a:t>03/08/2022</a:t>
+              <a:t>03/08/2024</a:t>
             </a:fld>
             <a:endParaRPr lang="vi-VN"/>
           </a:p>
@@ -750,7 +750,7 @@
           <a:lstStyle/>
           <a:p>
             <a:r>
-              <a:rPr lang="en-US" altLang="zh-TW" smtClean="0"/>
+              <a:rPr lang="en-US" altLang="zh-TW"/>
               <a:t>Click to edit Master title style</a:t>
             </a:r>
             <a:endParaRPr lang="zh-TW" altLang="en-US"/>
@@ -774,35 +774,35 @@
           <a:p>
             <a:pPr lvl="0"/>
             <a:r>
-              <a:rPr lang="en-US" altLang="zh-TW" smtClean="0"/>
+              <a:rPr lang="en-US" altLang="zh-TW"/>
               <a:t>Edit Master text styles</a:t>
             </a:r>
           </a:p>
           <a:p>
             <a:pPr lvl="1"/>
             <a:r>
-              <a:rPr lang="en-US" altLang="zh-TW" smtClean="0"/>
+              <a:rPr lang="en-US" altLang="zh-TW"/>
               <a:t>Second level</a:t>
             </a:r>
           </a:p>
           <a:p>
             <a:pPr lvl="2"/>
             <a:r>
-              <a:rPr lang="en-US" altLang="zh-TW" smtClean="0"/>
+              <a:rPr lang="en-US" altLang="zh-TW"/>
               <a:t>Third level</a:t>
             </a:r>
           </a:p>
           <a:p>
             <a:pPr lvl="3"/>
             <a:r>
-              <a:rPr lang="en-US" altLang="zh-TW" smtClean="0"/>
+              <a:rPr lang="en-US" altLang="zh-TW"/>
               <a:t>Fourth level</a:t>
             </a:r>
           </a:p>
           <a:p>
             <a:pPr lvl="4"/>
             <a:r>
-              <a:rPr lang="en-US" altLang="zh-TW" smtClean="0"/>
+              <a:rPr lang="en-US" altLang="zh-TW"/>
               <a:t>Fifth level</a:t>
             </a:r>
             <a:endParaRPr lang="zh-TW" altLang="en-US"/>
@@ -826,7 +826,7 @@
           <a:p>
             <a:fld id="{4708DAAA-A60A-4649-A77A-7F12CC5C96A6}" type="datetimeFigureOut">
               <a:rPr lang="vi-VN" smtClean="0"/>
-              <a:t>03/08/2022</a:t>
+              <a:t>03/08/2024</a:t>
             </a:fld>
             <a:endParaRPr lang="vi-VN"/>
           </a:p>
@@ -929,7 +929,7 @@
           </a:lstStyle>
           <a:p>
             <a:r>
-              <a:rPr lang="en-US" altLang="zh-TW" smtClean="0"/>
+              <a:rPr lang="en-US" altLang="zh-TW"/>
               <a:t>Click to edit Master title style</a:t>
             </a:r>
             <a:endParaRPr lang="zh-TW" altLang="en-US"/>
@@ -1049,7 +1049,7 @@
           <a:p>
             <a:pPr lvl="0"/>
             <a:r>
-              <a:rPr lang="en-US" altLang="zh-TW" smtClean="0"/>
+              <a:rPr lang="en-US" altLang="zh-TW"/>
               <a:t>Edit Master text styles</a:t>
             </a:r>
           </a:p>
@@ -1072,7 +1072,7 @@
           <a:p>
             <a:fld id="{4708DAAA-A60A-4649-A77A-7F12CC5C96A6}" type="datetimeFigureOut">
               <a:rPr lang="vi-VN" smtClean="0"/>
-              <a:t>03/08/2022</a:t>
+              <a:t>03/08/2024</a:t>
             </a:fld>
             <a:endParaRPr lang="vi-VN"/>
           </a:p>
@@ -1166,7 +1166,7 @@
           <a:lstStyle/>
           <a:p>
             <a:r>
-              <a:rPr lang="en-US" altLang="zh-TW" smtClean="0"/>
+              <a:rPr lang="en-US" altLang="zh-TW"/>
               <a:t>Click to edit Master title style</a:t>
             </a:r>
             <a:endParaRPr lang="zh-TW" altLang="en-US"/>
@@ -1223,35 +1223,35 @@
           <a:p>
             <a:pPr lvl="0"/>
             <a:r>
-              <a:rPr lang="en-US" altLang="zh-TW" smtClean="0"/>
+              <a:rPr lang="en-US" altLang="zh-TW"/>
               <a:t>Edit Master text styles</a:t>
             </a:r>
           </a:p>
           <a:p>
             <a:pPr lvl="1"/>
             <a:r>
-              <a:rPr lang="en-US" altLang="zh-TW" smtClean="0"/>
+              <a:rPr lang="en-US" altLang="zh-TW"/>
               <a:t>Second level</a:t>
             </a:r>
           </a:p>
           <a:p>
             <a:pPr lvl="2"/>
             <a:r>
-              <a:rPr lang="en-US" altLang="zh-TW" smtClean="0"/>
+              <a:rPr lang="en-US" altLang="zh-TW"/>
               <a:t>Third level</a:t>
             </a:r>
           </a:p>
           <a:p>
             <a:pPr lvl="3"/>
             <a:r>
-              <a:rPr lang="en-US" altLang="zh-TW" smtClean="0"/>
+              <a:rPr lang="en-US" altLang="zh-TW"/>
               <a:t>Fourth level</a:t>
             </a:r>
           </a:p>
           <a:p>
             <a:pPr lvl="4"/>
             <a:r>
-              <a:rPr lang="en-US" altLang="zh-TW" smtClean="0"/>
+              <a:rPr lang="en-US" altLang="zh-TW"/>
               <a:t>Fifth level</a:t>
             </a:r>
             <a:endParaRPr lang="zh-TW" altLang="en-US"/>
@@ -1308,35 +1308,35 @@
           <a:p>
             <a:pPr lvl="0"/>
             <a:r>
-              <a:rPr lang="en-US" altLang="zh-TW" smtClean="0"/>
+              <a:rPr lang="en-US" altLang="zh-TW"/>
               <a:t>Edit Master text styles</a:t>
             </a:r>
           </a:p>
           <a:p>
             <a:pPr lvl="1"/>
             <a:r>
-              <a:rPr lang="en-US" altLang="zh-TW" smtClean="0"/>
+              <a:rPr lang="en-US" altLang="zh-TW"/>
               <a:t>Second level</a:t>
             </a:r>
           </a:p>
           <a:p>
             <a:pPr lvl="2"/>
             <a:r>
-              <a:rPr lang="en-US" altLang="zh-TW" smtClean="0"/>
+              <a:rPr lang="en-US" altLang="zh-TW"/>
               <a:t>Third level</a:t>
             </a:r>
           </a:p>
           <a:p>
             <a:pPr lvl="3"/>
             <a:r>
-              <a:rPr lang="en-US" altLang="zh-TW" smtClean="0"/>
+              <a:rPr lang="en-US" altLang="zh-TW"/>
               <a:t>Fourth level</a:t>
             </a:r>
           </a:p>
           <a:p>
             <a:pPr lvl="4"/>
             <a:r>
-              <a:rPr lang="en-US" altLang="zh-TW" smtClean="0"/>
+              <a:rPr lang="en-US" altLang="zh-TW"/>
               <a:t>Fifth level</a:t>
             </a:r>
             <a:endParaRPr lang="zh-TW" altLang="en-US"/>
@@ -1360,7 +1360,7 @@
           <a:p>
             <a:fld id="{4708DAAA-A60A-4649-A77A-7F12CC5C96A6}" type="datetimeFigureOut">
               <a:rPr lang="vi-VN" smtClean="0"/>
-              <a:t>03/08/2022</a:t>
+              <a:t>03/08/2024</a:t>
             </a:fld>
             <a:endParaRPr lang="vi-VN"/>
           </a:p>
@@ -1458,7 +1458,7 @@
           </a:lstStyle>
           <a:p>
             <a:r>
-              <a:rPr lang="en-US" altLang="zh-TW" smtClean="0"/>
+              <a:rPr lang="en-US" altLang="zh-TW"/>
               <a:t>Click to edit Master title style</a:t>
             </a:r>
             <a:endParaRPr lang="zh-TW" altLang="en-US"/>
@@ -1524,7 +1524,7 @@
           <a:p>
             <a:pPr lvl="0"/>
             <a:r>
-              <a:rPr lang="en-US" altLang="zh-TW" smtClean="0"/>
+              <a:rPr lang="en-US" altLang="zh-TW"/>
               <a:t>Edit Master text styles</a:t>
             </a:r>
           </a:p>
@@ -1580,35 +1580,35 @@
           <a:p>
             <a:pPr lvl="0"/>
             <a:r>
-              <a:rPr lang="en-US" altLang="zh-TW" smtClean="0"/>
+              <a:rPr lang="en-US" altLang="zh-TW"/>
               <a:t>Edit Master text styles</a:t>
             </a:r>
           </a:p>
           <a:p>
             <a:pPr lvl="1"/>
             <a:r>
-              <a:rPr lang="en-US" altLang="zh-TW" smtClean="0"/>
+              <a:rPr lang="en-US" altLang="zh-TW"/>
               <a:t>Second level</a:t>
             </a:r>
           </a:p>
           <a:p>
             <a:pPr lvl="2"/>
             <a:r>
-              <a:rPr lang="en-US" altLang="zh-TW" smtClean="0"/>
+              <a:rPr lang="en-US" altLang="zh-TW"/>
               <a:t>Third level</a:t>
             </a:r>
           </a:p>
           <a:p>
             <a:pPr lvl="3"/>
             <a:r>
-              <a:rPr lang="en-US" altLang="zh-TW" smtClean="0"/>
+              <a:rPr lang="en-US" altLang="zh-TW"/>
               <a:t>Fourth level</a:t>
             </a:r>
           </a:p>
           <a:p>
             <a:pPr lvl="4"/>
             <a:r>
-              <a:rPr lang="en-US" altLang="zh-TW" smtClean="0"/>
+              <a:rPr lang="en-US" altLang="zh-TW"/>
               <a:t>Fifth level</a:t>
             </a:r>
             <a:endParaRPr lang="zh-TW" altLang="en-US"/>
@@ -1674,7 +1674,7 @@
           <a:p>
             <a:pPr lvl="0"/>
             <a:r>
-              <a:rPr lang="en-US" altLang="zh-TW" smtClean="0"/>
+              <a:rPr lang="en-US" altLang="zh-TW"/>
               <a:t>Edit Master text styles</a:t>
             </a:r>
           </a:p>
@@ -1730,35 +1730,35 @@
           <a:p>
             <a:pPr lvl="0"/>
             <a:r>
-              <a:rPr lang="en-US" altLang="zh-TW" smtClean="0"/>
+              <a:rPr lang="en-US" altLang="zh-TW"/>
               <a:t>Edit Master text styles</a:t>
             </a:r>
           </a:p>
           <a:p>
             <a:pPr lvl="1"/>
             <a:r>
-              <a:rPr lang="en-US" altLang="zh-TW" smtClean="0"/>
+              <a:rPr lang="en-US" altLang="zh-TW"/>
               <a:t>Second level</a:t>
             </a:r>
           </a:p>
           <a:p>
             <a:pPr lvl="2"/>
             <a:r>
-              <a:rPr lang="en-US" altLang="zh-TW" smtClean="0"/>
+              <a:rPr lang="en-US" altLang="zh-TW"/>
               <a:t>Third level</a:t>
             </a:r>
           </a:p>
           <a:p>
             <a:pPr lvl="3"/>
             <a:r>
-              <a:rPr lang="en-US" altLang="zh-TW" smtClean="0"/>
+              <a:rPr lang="en-US" altLang="zh-TW"/>
               <a:t>Fourth level</a:t>
             </a:r>
           </a:p>
           <a:p>
             <a:pPr lvl="4"/>
             <a:r>
-              <a:rPr lang="en-US" altLang="zh-TW" smtClean="0"/>
+              <a:rPr lang="en-US" altLang="zh-TW"/>
               <a:t>Fifth level</a:t>
             </a:r>
             <a:endParaRPr lang="zh-TW" altLang="en-US"/>
@@ -1782,7 +1782,7 @@
           <a:p>
             <a:fld id="{4708DAAA-A60A-4649-A77A-7F12CC5C96A6}" type="datetimeFigureOut">
               <a:rPr lang="vi-VN" smtClean="0"/>
-              <a:t>03/08/2022</a:t>
+              <a:t>03/08/2024</a:t>
             </a:fld>
             <a:endParaRPr lang="vi-VN"/>
           </a:p>
@@ -1876,7 +1876,7 @@
           <a:lstStyle/>
           <a:p>
             <a:r>
-              <a:rPr lang="en-US" altLang="zh-TW" smtClean="0"/>
+              <a:rPr lang="en-US" altLang="zh-TW"/>
               <a:t>Click to edit Master title style</a:t>
             </a:r>
             <a:endParaRPr lang="zh-TW" altLang="en-US"/>
@@ -1900,7 +1900,7 @@
           <a:p>
             <a:fld id="{4708DAAA-A60A-4649-A77A-7F12CC5C96A6}" type="datetimeFigureOut">
               <a:rPr lang="vi-VN" smtClean="0"/>
-              <a:t>03/08/2022</a:t>
+              <a:t>03/08/2024</a:t>
             </a:fld>
             <a:endParaRPr lang="vi-VN"/>
           </a:p>
@@ -1995,7 +1995,7 @@
           <a:p>
             <a:fld id="{4708DAAA-A60A-4649-A77A-7F12CC5C96A6}" type="datetimeFigureOut">
               <a:rPr lang="vi-VN" smtClean="0"/>
-              <a:t>03/08/2022</a:t>
+              <a:t>03/08/2024</a:t>
             </a:fld>
             <a:endParaRPr lang="vi-VN"/>
           </a:p>
@@ -2098,7 +2098,7 @@
           </a:lstStyle>
           <a:p>
             <a:r>
-              <a:rPr lang="en-US" altLang="zh-TW" smtClean="0"/>
+              <a:rPr lang="en-US" altLang="zh-TW"/>
               <a:t>Click to edit Master title style</a:t>
             </a:r>
             <a:endParaRPr lang="zh-TW" altLang="en-US"/>
@@ -2155,35 +2155,35 @@
           <a:p>
             <a:pPr lvl="0"/>
             <a:r>
-              <a:rPr lang="en-US" altLang="zh-TW" smtClean="0"/>
+              <a:rPr lang="en-US" altLang="zh-TW"/>
               <a:t>Edit Master text styles</a:t>
             </a:r>
           </a:p>
           <a:p>
             <a:pPr lvl="1"/>
             <a:r>
-              <a:rPr lang="en-US" altLang="zh-TW" smtClean="0"/>
+              <a:rPr lang="en-US" altLang="zh-TW"/>
               <a:t>Second level</a:t>
             </a:r>
           </a:p>
           <a:p>
             <a:pPr lvl="2"/>
             <a:r>
-              <a:rPr lang="en-US" altLang="zh-TW" smtClean="0"/>
+              <a:rPr lang="en-US" altLang="zh-TW"/>
               <a:t>Third level</a:t>
             </a:r>
           </a:p>
           <a:p>
             <a:pPr lvl="3"/>
             <a:r>
-              <a:rPr lang="en-US" altLang="zh-TW" smtClean="0"/>
+              <a:rPr lang="en-US" altLang="zh-TW"/>
               <a:t>Fourth level</a:t>
             </a:r>
           </a:p>
           <a:p>
             <a:pPr lvl="4"/>
             <a:r>
-              <a:rPr lang="en-US" altLang="zh-TW" smtClean="0"/>
+              <a:rPr lang="en-US" altLang="zh-TW"/>
               <a:t>Fifth level</a:t>
             </a:r>
             <a:endParaRPr lang="zh-TW" altLang="en-US"/>
@@ -2249,7 +2249,7 @@
           <a:p>
             <a:pPr lvl="0"/>
             <a:r>
-              <a:rPr lang="en-US" altLang="zh-TW" smtClean="0"/>
+              <a:rPr lang="en-US" altLang="zh-TW"/>
               <a:t>Edit Master text styles</a:t>
             </a:r>
           </a:p>
@@ -2272,7 +2272,7 @@
           <a:p>
             <a:fld id="{4708DAAA-A60A-4649-A77A-7F12CC5C96A6}" type="datetimeFigureOut">
               <a:rPr lang="vi-VN" smtClean="0"/>
-              <a:t>03/08/2022</a:t>
+              <a:t>03/08/2024</a:t>
             </a:fld>
             <a:endParaRPr lang="vi-VN"/>
           </a:p>
@@ -2375,7 +2375,7 @@
           </a:lstStyle>
           <a:p>
             <a:r>
-              <a:rPr lang="en-US" altLang="zh-TW" smtClean="0"/>
+              <a:rPr lang="en-US" altLang="zh-TW"/>
               <a:t>Click to edit Master title style</a:t>
             </a:r>
             <a:endParaRPr lang="zh-TW" altLang="en-US"/>
@@ -2440,7 +2440,7 @@
           </a:lstStyle>
           <a:p>
             <a:r>
-              <a:rPr lang="en-US" altLang="zh-TW" smtClean="0"/>
+              <a:rPr lang="en-US" altLang="zh-TW"/>
               <a:t>Click icon to add picture</a:t>
             </a:r>
             <a:endParaRPr lang="zh-TW" altLang="en-US"/>
@@ -2506,7 +2506,7 @@
           <a:p>
             <a:pPr lvl="0"/>
             <a:r>
-              <a:rPr lang="en-US" altLang="zh-TW" smtClean="0"/>
+              <a:rPr lang="en-US" altLang="zh-TW"/>
               <a:t>Edit Master text styles</a:t>
             </a:r>
           </a:p>
@@ -2529,7 +2529,7 @@
           <a:p>
             <a:fld id="{4708DAAA-A60A-4649-A77A-7F12CC5C96A6}" type="datetimeFigureOut">
               <a:rPr lang="vi-VN" smtClean="0"/>
-              <a:t>03/08/2022</a:t>
+              <a:t>03/08/2024</a:t>
             </a:fld>
             <a:endParaRPr lang="vi-VN"/>
           </a:p>
@@ -2643,10 +2643,9 @@
           <a:lstStyle/>
           <a:p>
             <a:r>
-              <a:rPr lang="zh-TW" altLang="en-US" smtClean="0"/>
+              <a:rPr lang="zh-TW" altLang="en-US"/>
               <a:t>按一下以編輯母片標題樣式</a:t>
             </a:r>
-            <a:endParaRPr lang="zh-TW" altLang="en-US"/>
           </a:p>
         </p:txBody>
       </p:sp>
@@ -2677,38 +2676,37 @@
           <a:p>
             <a:pPr lvl="0"/>
             <a:r>
-              <a:rPr lang="zh-TW" altLang="en-US" smtClean="0"/>
+              <a:rPr lang="zh-TW" altLang="en-US"/>
               <a:t>按一下以編輯母片文字樣式</a:t>
             </a:r>
           </a:p>
           <a:p>
             <a:pPr lvl="1"/>
             <a:r>
-              <a:rPr lang="zh-TW" altLang="en-US" smtClean="0"/>
+              <a:rPr lang="zh-TW" altLang="en-US"/>
               <a:t>第二層</a:t>
             </a:r>
           </a:p>
           <a:p>
             <a:pPr lvl="2"/>
             <a:r>
-              <a:rPr lang="zh-TW" altLang="en-US" smtClean="0"/>
+              <a:rPr lang="zh-TW" altLang="en-US"/>
               <a:t>第三層</a:t>
             </a:r>
           </a:p>
           <a:p>
             <a:pPr lvl="3"/>
             <a:r>
-              <a:rPr lang="zh-TW" altLang="en-US" smtClean="0"/>
+              <a:rPr lang="zh-TW" altLang="en-US"/>
               <a:t>第四層</a:t>
             </a:r>
           </a:p>
           <a:p>
             <a:pPr lvl="4"/>
             <a:r>
-              <a:rPr lang="zh-TW" altLang="en-US" smtClean="0"/>
+              <a:rPr lang="zh-TW" altLang="en-US"/>
               <a:t>第五層</a:t>
             </a:r>
-            <a:endParaRPr lang="zh-TW" altLang="en-US"/>
           </a:p>
         </p:txBody>
       </p:sp>
@@ -2747,7 +2745,7 @@
           <a:p>
             <a:fld id="{4708DAAA-A60A-4649-A77A-7F12CC5C96A6}" type="datetimeFigureOut">
               <a:rPr lang="vi-VN" smtClean="0"/>
-              <a:t>03/08/2022</a:t>
+              <a:t>03/08/2024</a:t>
             </a:fld>
             <a:endParaRPr lang="vi-VN"/>
           </a:p>
@@ -3161,7 +3159,7 @@
           </a:lstStyle>
           <a:p>
             <a:r>
-              <a:rPr lang="zh-CN" altLang="en-US" sz="7200" b="1" i="1" dirty="0" smtClean="0">
+              <a:rPr lang="zh-CN" altLang="en-US" sz="7200" b="1" i="1" dirty="0">
                 <a:solidFill>
                   <a:srgbClr val="000066"/>
                 </a:solidFill>
@@ -3175,24 +3173,7 @@
                 <a:latin typeface="微軟正黑體" pitchFamily="34" charset="-120"/>
                 <a:ea typeface="微軟正黑體" pitchFamily="34" charset="-120"/>
               </a:rPr>
-              <a:t>平</a:t>
-            </a:r>
-            <a:r>
-              <a:rPr lang="zh-CN" altLang="en-US" sz="7200" b="1" i="1" dirty="0">
-                <a:solidFill>
-                  <a:srgbClr val="000066"/>
-                </a:solidFill>
-                <a:effectLst>
-                  <a:outerShdw blurRad="38100" dist="38100" dir="2700000" algn="tl">
-                    <a:srgbClr val="000000">
-                      <a:alpha val="43137"/>
-                    </a:srgbClr>
-                  </a:outerShdw>
-                </a:effectLst>
-                <a:latin typeface="微軟正黑體" pitchFamily="34" charset="-120"/>
-                <a:ea typeface="微軟正黑體" pitchFamily="34" charset="-120"/>
-              </a:rPr>
-              <a:t>安的路</a:t>
+              <a:t>平安的路</a:t>
             </a:r>
             <a:endParaRPr lang="zh-TW" altLang="en-US" sz="7200" b="1" i="1" dirty="0">
               <a:solidFill>
@@ -3250,7 +3231,7 @@
           </a:lstStyle>
           <a:p>
             <a:r>
-              <a:rPr lang="vi-VN" sz="5400" b="1" i="1" dirty="0" smtClean="0">
+              <a:rPr lang="vi-VN" sz="5400" b="1" i="1" dirty="0">
                 <a:solidFill>
                   <a:srgbClr val="660033"/>
                 </a:solidFill>
@@ -3265,25 +3246,7 @@
                 <a:ea typeface="微軟正黑體" pitchFamily="34" charset="-120"/>
                 <a:cs typeface="Calibri" panose="020F0502020204030204" pitchFamily="34" charset="0"/>
               </a:rPr>
-              <a:t>Con </a:t>
-            </a:r>
-            <a:r>
-              <a:rPr lang="vi-VN" sz="5400" b="1" i="1" dirty="0">
-                <a:solidFill>
-                  <a:srgbClr val="660033"/>
-                </a:solidFill>
-                <a:effectLst>
-                  <a:outerShdw blurRad="38100" dist="38100" dir="2700000" algn="tl">
-                    <a:srgbClr val="000000">
-                      <a:alpha val="43137"/>
-                    </a:srgbClr>
-                  </a:outerShdw>
-                </a:effectLst>
-                <a:latin typeface="Calibri" panose="020F0502020204030204" pitchFamily="34" charset="0"/>
-                <a:ea typeface="微軟正黑體" pitchFamily="34" charset="-120"/>
-                <a:cs typeface="Calibri" panose="020F0502020204030204" pitchFamily="34" charset="0"/>
-              </a:rPr>
-              <a:t>đường bình an</a:t>
+              <a:t>Con đường bình an</a:t>
             </a:r>
             <a:endParaRPr lang="zh-TW" altLang="en-US" sz="5400" b="1" i="1" dirty="0">
               <a:solidFill>
@@ -3571,7 +3534,7 @@
         <p:spPr>
           <a:xfrm>
             <a:off x="0" y="5253203"/>
-            <a:ext cx="12192000" cy="748988"/>
+            <a:ext cx="12192000" cy="584775"/>
           </a:xfrm>
           <a:prstGeom prst="rect">
             <a:avLst/>
@@ -3586,54 +3549,39 @@
           <a:p>
             <a:pPr algn="ctr"/>
             <a:r>
-              <a:rPr lang="en-US" sz="4267" b="1" dirty="0">
+              <a:rPr lang="en-US" sz="3200" b="1" dirty="0">
                 <a:solidFill>
                   <a:srgbClr val="000066"/>
                 </a:solidFill>
-                <a:effectLst/>
                 <a:latin typeface="Microsoft JhengHei" panose="020B0604030504040204" pitchFamily="34" charset="-120"/>
                 <a:ea typeface="Microsoft JhengHei" panose="020B0604030504040204" pitchFamily="34" charset="-120"/>
               </a:rPr>
               <a:t>( </a:t>
             </a:r>
             <a:r>
-              <a:rPr lang="zh-CN" altLang="en-US" sz="4267" b="1" dirty="0" smtClean="0">
+              <a:rPr lang="zh-CN" altLang="en-US" sz="3200" b="1" dirty="0">
                 <a:solidFill>
                   <a:srgbClr val="000066"/>
                 </a:solidFill>
-                <a:effectLst/>
                 <a:latin typeface="Microsoft JhengHei" panose="020B0604030504040204" pitchFamily="34" charset="-120"/>
                 <a:ea typeface="Microsoft JhengHei" panose="020B0604030504040204" pitchFamily="34" charset="-120"/>
               </a:rPr>
-              <a:t>副</a:t>
-            </a:r>
-            <a:r>
-              <a:rPr lang="en-US" sz="4267" b="1" dirty="0" smtClean="0">
+              <a:t>副歌</a:t>
+            </a:r>
+            <a:r>
+              <a:rPr lang="en-US" sz="3200" b="1" dirty="0">
                 <a:solidFill>
                   <a:srgbClr val="000066"/>
                 </a:solidFill>
-                <a:effectLst/>
                 <a:latin typeface="Microsoft JhengHei" panose="020B0604030504040204" pitchFamily="34" charset="-120"/>
                 <a:ea typeface="Microsoft JhengHei" panose="020B0604030504040204" pitchFamily="34" charset="-120"/>
               </a:rPr>
-              <a:t> </a:t>
-            </a:r>
-            <a:r>
-              <a:rPr lang="en-US" sz="4267" b="1" dirty="0">
-                <a:solidFill>
-                  <a:srgbClr val="000066"/>
-                </a:solidFill>
-                <a:effectLst/>
-                <a:latin typeface="Microsoft JhengHei" panose="020B0604030504040204" pitchFamily="34" charset="-120"/>
-                <a:ea typeface="Microsoft JhengHei" panose="020B0604030504040204" pitchFamily="34" charset="-120"/>
-              </a:rPr>
-              <a:t>)</a:t>
-            </a:r>
-            <a:endParaRPr lang="vi-VN" sz="4267" b="1" dirty="0">
+              <a:t> )</a:t>
+            </a:r>
+            <a:endParaRPr lang="vi-VN" sz="3200" b="1" dirty="0">
               <a:solidFill>
                 <a:srgbClr val="000066"/>
               </a:solidFill>
-              <a:effectLst/>
               <a:ea typeface="Microsoft JhengHei" panose="020B0604030504040204" pitchFamily="34" charset="-120"/>
             </a:endParaRPr>
           </a:p>
@@ -3896,18 +3844,7 @@
                 <a:ea typeface="微軟正黑體" pitchFamily="34" charset="-120"/>
                 <a:cs typeface="Calibri" panose="020F0502020204030204" pitchFamily="34" charset="0"/>
               </a:rPr>
-              <a:t>điển </a:t>
-            </a:r>
-            <a:r>
-              <a:rPr lang="vi-VN" sz="4000" b="1" smtClean="0">
-                <a:solidFill>
-                  <a:srgbClr val="660033"/>
-                </a:solidFill>
-                <a:latin typeface="Calibri" panose="020F0502020204030204" pitchFamily="34" charset="0"/>
-                <a:ea typeface="微軟正黑體" pitchFamily="34" charset="-120"/>
-                <a:cs typeface="Calibri" panose="020F0502020204030204" pitchFamily="34" charset="0"/>
-              </a:rPr>
-              <a:t>diệu </a:t>
+              <a:t>điển diệu </a:t>
             </a:r>
             <a:r>
               <a:rPr lang="vi-VN" sz="4000" b="1" dirty="0">
@@ -3940,7 +3877,7 @@
         <p:spPr>
           <a:xfrm>
             <a:off x="0" y="5253203"/>
-            <a:ext cx="12192000" cy="748988"/>
+            <a:ext cx="12192000" cy="584775"/>
           </a:xfrm>
           <a:prstGeom prst="rect">
             <a:avLst/>
@@ -3955,54 +3892,39 @@
           <a:p>
             <a:pPr algn="ctr"/>
             <a:r>
-              <a:rPr lang="en-US" sz="4267" b="1" dirty="0">
+              <a:rPr lang="en-US" sz="3200" b="1" dirty="0">
                 <a:solidFill>
                   <a:srgbClr val="000066"/>
                 </a:solidFill>
-                <a:effectLst/>
                 <a:latin typeface="Microsoft JhengHei" panose="020B0604030504040204" pitchFamily="34" charset="-120"/>
                 <a:ea typeface="Microsoft JhengHei" panose="020B0604030504040204" pitchFamily="34" charset="-120"/>
               </a:rPr>
               <a:t>( </a:t>
             </a:r>
             <a:r>
-              <a:rPr lang="zh-CN" altLang="en-US" sz="4267" b="1" dirty="0" smtClean="0">
+              <a:rPr lang="zh-CN" altLang="en-US" sz="3200" b="1" dirty="0">
                 <a:solidFill>
                   <a:srgbClr val="000066"/>
                 </a:solidFill>
-                <a:effectLst/>
                 <a:latin typeface="Microsoft JhengHei" panose="020B0604030504040204" pitchFamily="34" charset="-120"/>
                 <a:ea typeface="Microsoft JhengHei" panose="020B0604030504040204" pitchFamily="34" charset="-120"/>
               </a:rPr>
-              <a:t>副</a:t>
-            </a:r>
-            <a:r>
-              <a:rPr lang="en-US" sz="4267" b="1" dirty="0" smtClean="0">
+              <a:t>副歌</a:t>
+            </a:r>
+            <a:r>
+              <a:rPr lang="en-US" sz="3200" b="1" dirty="0">
                 <a:solidFill>
                   <a:srgbClr val="000066"/>
                 </a:solidFill>
-                <a:effectLst/>
                 <a:latin typeface="Microsoft JhengHei" panose="020B0604030504040204" pitchFamily="34" charset="-120"/>
                 <a:ea typeface="Microsoft JhengHei" panose="020B0604030504040204" pitchFamily="34" charset="-120"/>
               </a:rPr>
-              <a:t> </a:t>
-            </a:r>
-            <a:r>
-              <a:rPr lang="en-US" sz="4267" b="1" dirty="0">
-                <a:solidFill>
-                  <a:srgbClr val="000066"/>
-                </a:solidFill>
-                <a:effectLst/>
-                <a:latin typeface="Microsoft JhengHei" panose="020B0604030504040204" pitchFamily="34" charset="-120"/>
-                <a:ea typeface="Microsoft JhengHei" panose="020B0604030504040204" pitchFamily="34" charset="-120"/>
-              </a:rPr>
-              <a:t>)</a:t>
-            </a:r>
-            <a:endParaRPr lang="vi-VN" sz="4267" b="1" dirty="0">
+              <a:t> )</a:t>
+            </a:r>
+            <a:endParaRPr lang="vi-VN" sz="3200" b="1" dirty="0">
               <a:solidFill>
                 <a:srgbClr val="000066"/>
               </a:solidFill>
-              <a:effectLst/>
               <a:ea typeface="Microsoft JhengHei" panose="020B0604030504040204" pitchFamily="34" charset="-120"/>
             </a:endParaRPr>
           </a:p>
@@ -4276,7 +4198,7 @@
         <p:spPr>
           <a:xfrm>
             <a:off x="0" y="5253203"/>
-            <a:ext cx="12192000" cy="748988"/>
+            <a:ext cx="12192000" cy="584775"/>
           </a:xfrm>
           <a:prstGeom prst="rect">
             <a:avLst/>
@@ -4291,54 +4213,39 @@
           <a:p>
             <a:pPr algn="ctr"/>
             <a:r>
-              <a:rPr lang="en-US" sz="4267" b="1" dirty="0">
+              <a:rPr lang="en-US" sz="3200" b="1" dirty="0">
                 <a:solidFill>
                   <a:srgbClr val="000066"/>
                 </a:solidFill>
-                <a:effectLst/>
                 <a:latin typeface="Microsoft JhengHei" panose="020B0604030504040204" pitchFamily="34" charset="-120"/>
                 <a:ea typeface="Microsoft JhengHei" panose="020B0604030504040204" pitchFamily="34" charset="-120"/>
               </a:rPr>
               <a:t>( </a:t>
             </a:r>
             <a:r>
-              <a:rPr lang="zh-CN" altLang="en-US" sz="4267" b="1" dirty="0" smtClean="0">
+              <a:rPr lang="zh-CN" altLang="en-US" sz="3200" b="1" dirty="0">
                 <a:solidFill>
                   <a:srgbClr val="000066"/>
                 </a:solidFill>
-                <a:effectLst/>
                 <a:latin typeface="Microsoft JhengHei" panose="020B0604030504040204" pitchFamily="34" charset="-120"/>
                 <a:ea typeface="Microsoft JhengHei" panose="020B0604030504040204" pitchFamily="34" charset="-120"/>
               </a:rPr>
-              <a:t>副</a:t>
-            </a:r>
-            <a:r>
-              <a:rPr lang="en-US" sz="4267" b="1" dirty="0" smtClean="0">
+              <a:t>副歌</a:t>
+            </a:r>
+            <a:r>
+              <a:rPr lang="en-US" sz="3200" b="1" dirty="0">
                 <a:solidFill>
                   <a:srgbClr val="000066"/>
                 </a:solidFill>
-                <a:effectLst/>
                 <a:latin typeface="Microsoft JhengHei" panose="020B0604030504040204" pitchFamily="34" charset="-120"/>
                 <a:ea typeface="Microsoft JhengHei" panose="020B0604030504040204" pitchFamily="34" charset="-120"/>
               </a:rPr>
-              <a:t> </a:t>
-            </a:r>
-            <a:r>
-              <a:rPr lang="en-US" sz="4267" b="1" dirty="0">
-                <a:solidFill>
-                  <a:srgbClr val="000066"/>
-                </a:solidFill>
-                <a:effectLst/>
-                <a:latin typeface="Microsoft JhengHei" panose="020B0604030504040204" pitchFamily="34" charset="-120"/>
-                <a:ea typeface="Microsoft JhengHei" panose="020B0604030504040204" pitchFamily="34" charset="-120"/>
-              </a:rPr>
-              <a:t>)</a:t>
-            </a:r>
-            <a:endParaRPr lang="vi-VN" sz="4267" b="1" dirty="0">
+              <a:t> )</a:t>
+            </a:r>
+            <a:endParaRPr lang="vi-VN" sz="3200" b="1" dirty="0">
               <a:solidFill>
                 <a:srgbClr val="000066"/>
               </a:solidFill>
-              <a:effectLst/>
               <a:ea typeface="Microsoft JhengHei" panose="020B0604030504040204" pitchFamily="34" charset="-120"/>
             </a:endParaRPr>
           </a:p>
@@ -4612,7 +4519,7 @@
         <p:spPr>
           <a:xfrm>
             <a:off x="0" y="5253203"/>
-            <a:ext cx="12192000" cy="748988"/>
+            <a:ext cx="12192000" cy="584775"/>
           </a:xfrm>
           <a:prstGeom prst="rect">
             <a:avLst/>
@@ -4627,54 +4534,39 @@
           <a:p>
             <a:pPr algn="ctr"/>
             <a:r>
-              <a:rPr lang="en-US" sz="4267" b="1" dirty="0">
+              <a:rPr lang="en-US" sz="3200" b="1" dirty="0">
                 <a:solidFill>
                   <a:srgbClr val="000066"/>
                 </a:solidFill>
-                <a:effectLst/>
                 <a:latin typeface="Microsoft JhengHei" panose="020B0604030504040204" pitchFamily="34" charset="-120"/>
                 <a:ea typeface="Microsoft JhengHei" panose="020B0604030504040204" pitchFamily="34" charset="-120"/>
               </a:rPr>
               <a:t>( </a:t>
             </a:r>
             <a:r>
-              <a:rPr lang="zh-CN" altLang="en-US" sz="4267" b="1" dirty="0" smtClean="0">
+              <a:rPr lang="zh-CN" altLang="en-US" sz="3200" b="1" dirty="0">
                 <a:solidFill>
                   <a:srgbClr val="000066"/>
                 </a:solidFill>
-                <a:effectLst/>
                 <a:latin typeface="Microsoft JhengHei" panose="020B0604030504040204" pitchFamily="34" charset="-120"/>
                 <a:ea typeface="Microsoft JhengHei" panose="020B0604030504040204" pitchFamily="34" charset="-120"/>
               </a:rPr>
-              <a:t>副</a:t>
-            </a:r>
-            <a:r>
-              <a:rPr lang="en-US" sz="4267" b="1" dirty="0" smtClean="0">
+              <a:t>副歌</a:t>
+            </a:r>
+            <a:r>
+              <a:rPr lang="en-US" sz="3200" b="1" dirty="0">
                 <a:solidFill>
                   <a:srgbClr val="000066"/>
                 </a:solidFill>
-                <a:effectLst/>
                 <a:latin typeface="Microsoft JhengHei" panose="020B0604030504040204" pitchFamily="34" charset="-120"/>
                 <a:ea typeface="Microsoft JhengHei" panose="020B0604030504040204" pitchFamily="34" charset="-120"/>
               </a:rPr>
-              <a:t> </a:t>
-            </a:r>
-            <a:r>
-              <a:rPr lang="en-US" sz="4267" b="1" dirty="0">
-                <a:solidFill>
-                  <a:srgbClr val="000066"/>
-                </a:solidFill>
-                <a:effectLst/>
-                <a:latin typeface="Microsoft JhengHei" panose="020B0604030504040204" pitchFamily="34" charset="-120"/>
-                <a:ea typeface="Microsoft JhengHei" panose="020B0604030504040204" pitchFamily="34" charset="-120"/>
-              </a:rPr>
-              <a:t>)</a:t>
-            </a:r>
-            <a:endParaRPr lang="vi-VN" sz="4267" b="1" dirty="0">
+              <a:t> )</a:t>
+            </a:r>
+            <a:endParaRPr lang="vi-VN" sz="3200" b="1" dirty="0">
               <a:solidFill>
                 <a:srgbClr val="000066"/>
               </a:solidFill>
-              <a:effectLst/>
               <a:ea typeface="Microsoft JhengHei" panose="020B0604030504040204" pitchFamily="34" charset="-120"/>
             </a:endParaRPr>
           </a:p>
@@ -4941,7 +4833,7 @@
         <p:spPr>
           <a:xfrm>
             <a:off x="0" y="5253203"/>
-            <a:ext cx="12192000" cy="748988"/>
+            <a:ext cx="12192000" cy="584775"/>
           </a:xfrm>
           <a:prstGeom prst="rect">
             <a:avLst/>
@@ -4956,54 +4848,39 @@
           <a:p>
             <a:pPr algn="ctr"/>
             <a:r>
-              <a:rPr lang="en-US" sz="4267" b="1" dirty="0">
+              <a:rPr lang="en-US" sz="3200" b="1" dirty="0">
                 <a:solidFill>
                   <a:srgbClr val="000066"/>
                 </a:solidFill>
-                <a:effectLst/>
                 <a:latin typeface="Microsoft JhengHei" panose="020B0604030504040204" pitchFamily="34" charset="-120"/>
                 <a:ea typeface="Microsoft JhengHei" panose="020B0604030504040204" pitchFamily="34" charset="-120"/>
               </a:rPr>
               <a:t>( </a:t>
             </a:r>
             <a:r>
-              <a:rPr lang="zh-CN" altLang="en-US" sz="4267" b="1" dirty="0" smtClean="0">
+              <a:rPr lang="zh-CN" altLang="en-US" sz="3200" b="1" dirty="0">
                 <a:solidFill>
                   <a:srgbClr val="000066"/>
                 </a:solidFill>
-                <a:effectLst/>
                 <a:latin typeface="Microsoft JhengHei" panose="020B0604030504040204" pitchFamily="34" charset="-120"/>
                 <a:ea typeface="Microsoft JhengHei" panose="020B0604030504040204" pitchFamily="34" charset="-120"/>
               </a:rPr>
-              <a:t>副</a:t>
-            </a:r>
-            <a:r>
-              <a:rPr lang="en-US" sz="4267" b="1" dirty="0" smtClean="0">
+              <a:t>副歌</a:t>
+            </a:r>
+            <a:r>
+              <a:rPr lang="en-US" sz="3200" b="1" dirty="0">
                 <a:solidFill>
                   <a:srgbClr val="000066"/>
                 </a:solidFill>
-                <a:effectLst/>
                 <a:latin typeface="Microsoft JhengHei" panose="020B0604030504040204" pitchFamily="34" charset="-120"/>
                 <a:ea typeface="Microsoft JhengHei" panose="020B0604030504040204" pitchFamily="34" charset="-120"/>
               </a:rPr>
-              <a:t> </a:t>
-            </a:r>
-            <a:r>
-              <a:rPr lang="en-US" sz="4267" b="1" dirty="0">
-                <a:solidFill>
-                  <a:srgbClr val="000066"/>
-                </a:solidFill>
-                <a:effectLst/>
-                <a:latin typeface="Microsoft JhengHei" panose="020B0604030504040204" pitchFamily="34" charset="-120"/>
-                <a:ea typeface="Microsoft JhengHei" panose="020B0604030504040204" pitchFamily="34" charset="-120"/>
-              </a:rPr>
-              <a:t>)</a:t>
-            </a:r>
-            <a:endParaRPr lang="vi-VN" sz="4267" b="1" dirty="0">
+              <a:t> )</a:t>
+            </a:r>
+            <a:endParaRPr lang="vi-VN" sz="3200" b="1" dirty="0">
               <a:solidFill>
                 <a:srgbClr val="000066"/>
               </a:solidFill>
-              <a:effectLst/>
               <a:ea typeface="Microsoft JhengHei" panose="020B0604030504040204" pitchFamily="34" charset="-120"/>
             </a:endParaRPr>
           </a:p>
@@ -5065,44 +4942,14 @@
               <a:buNone/>
             </a:pPr>
             <a:r>
-              <a:rPr lang="zh-TW" altLang="en-US" sz="6400" b="1" dirty="0" smtClean="0">
+              <a:rPr lang="zh-TW" altLang="en-US" sz="6400" b="1" dirty="0">
                 <a:solidFill>
                   <a:srgbClr val="000066"/>
                 </a:solidFill>
                 <a:latin typeface="微軟正黑體" pitchFamily="34" charset="-120"/>
                 <a:ea typeface="微軟正黑體" pitchFamily="34" charset="-120"/>
               </a:rPr>
-              <a:t>天</a:t>
-            </a:r>
-            <a:r>
-              <a:rPr lang="zh-TW" altLang="en-US" sz="6400" b="1" dirty="0">
-                <a:solidFill>
-                  <a:srgbClr val="000066"/>
-                </a:solidFill>
-                <a:latin typeface="微軟正黑體" pitchFamily="34" charset="-120"/>
-                <a:ea typeface="微軟正黑體" pitchFamily="34" charset="-120"/>
-              </a:rPr>
-              <a:t>下人間 </a:t>
-            </a:r>
-            <a:r>
-              <a:rPr lang="zh-TW" altLang="en-US" sz="6400" b="1" dirty="0" smtClean="0">
-                <a:solidFill>
-                  <a:srgbClr val="000066"/>
-                </a:solidFill>
-                <a:latin typeface="微軟正黑體" pitchFamily="34" charset="-120"/>
-                <a:ea typeface="微軟正黑體" pitchFamily="34" charset="-120"/>
-              </a:rPr>
-              <a:t> 有</a:t>
-            </a:r>
-            <a:r>
-              <a:rPr lang="zh-TW" altLang="en-US" sz="6400" b="1" dirty="0">
-                <a:solidFill>
-                  <a:srgbClr val="000066"/>
-                </a:solidFill>
-                <a:latin typeface="微軟正黑體" pitchFamily="34" charset="-120"/>
-                <a:ea typeface="微軟正黑體" pitchFamily="34" charset="-120"/>
-              </a:rPr>
-              <a:t>位真神</a:t>
+              <a:t>天下人間  有位真神</a:t>
             </a:r>
             <a:endParaRPr lang="en-US" altLang="zh-CN" sz="6400" b="1" dirty="0">
               <a:solidFill>
@@ -5277,7 +5124,7 @@
               <a:buNone/>
             </a:pPr>
             <a:r>
-              <a:rPr lang="vi-VN" sz="4000" b="1" dirty="0" smtClean="0">
+              <a:rPr lang="vi-VN" sz="4000" b="1" dirty="0">
                 <a:solidFill>
                   <a:srgbClr val="660033"/>
                 </a:solidFill>
@@ -5285,18 +5132,7 @@
                 <a:ea typeface="微軟正黑體" pitchFamily="34" charset="-120"/>
                 <a:cs typeface="Calibri" panose="020F0502020204030204" pitchFamily="34" charset="0"/>
               </a:rPr>
-              <a:t>Trên </a:t>
-            </a:r>
-            <a:r>
-              <a:rPr lang="vi-VN" sz="4000" b="1" dirty="0">
-                <a:solidFill>
-                  <a:srgbClr val="660033"/>
-                </a:solidFill>
-                <a:latin typeface="Calibri" panose="020F0502020204030204" pitchFamily="34" charset="0"/>
-                <a:ea typeface="微軟正黑體" pitchFamily="34" charset="-120"/>
-                <a:cs typeface="Calibri" panose="020F0502020204030204" pitchFamily="34" charset="0"/>
-              </a:rPr>
-              <a:t>thế gian này có một Chân Thần</a:t>
+              <a:t>Trên thế gian này có một Chân Thần</a:t>
             </a:r>
             <a:endParaRPr lang="en-US" sz="4000" b="1" dirty="0">
               <a:solidFill>
@@ -5318,7 +5154,7 @@
         <p:spPr>
           <a:xfrm>
             <a:off x="0" y="5253203"/>
-            <a:ext cx="12192000" cy="748988"/>
+            <a:ext cx="12192000" cy="584775"/>
           </a:xfrm>
           <a:prstGeom prst="rect">
             <a:avLst/>
@@ -5333,7 +5169,7 @@
           <a:p>
             <a:pPr algn="ctr"/>
             <a:r>
-              <a:rPr lang="en-US" sz="4267" b="1" dirty="0">
+              <a:rPr lang="en-US" sz="3200" b="1" dirty="0">
                 <a:solidFill>
                   <a:srgbClr val="000066"/>
                 </a:solidFill>
@@ -5344,7 +5180,7 @@
               <a:t>( </a:t>
             </a:r>
             <a:r>
-              <a:rPr lang="zh-CN" altLang="en-US" sz="4267" b="1" dirty="0" smtClean="0">
+              <a:rPr lang="zh-CN" altLang="en-US" sz="3200" b="1" dirty="0">
                 <a:solidFill>
                   <a:srgbClr val="000066"/>
                 </a:solidFill>
@@ -5352,10 +5188,10 @@
                 <a:latin typeface="Microsoft JhengHei" panose="020B0604030504040204" pitchFamily="34" charset="-120"/>
                 <a:ea typeface="Microsoft JhengHei" panose="020B0604030504040204" pitchFamily="34" charset="-120"/>
               </a:rPr>
-              <a:t>正</a:t>
-            </a:r>
-            <a:r>
-              <a:rPr lang="en-US" sz="4267" b="1" dirty="0" smtClean="0">
+              <a:t>正歌</a:t>
+            </a:r>
+            <a:r>
+              <a:rPr lang="en-US" sz="3200" b="1" dirty="0">
                 <a:solidFill>
                   <a:srgbClr val="000066"/>
                 </a:solidFill>
@@ -5363,20 +5199,9 @@
                 <a:latin typeface="Microsoft JhengHei" panose="020B0604030504040204" pitchFamily="34" charset="-120"/>
                 <a:ea typeface="Microsoft JhengHei" panose="020B0604030504040204" pitchFamily="34" charset="-120"/>
               </a:rPr>
-              <a:t> </a:t>
-            </a:r>
-            <a:r>
-              <a:rPr lang="en-US" sz="4267" b="1" dirty="0">
-                <a:solidFill>
-                  <a:srgbClr val="000066"/>
-                </a:solidFill>
-                <a:effectLst/>
-                <a:latin typeface="Microsoft JhengHei" panose="020B0604030504040204" pitchFamily="34" charset="-120"/>
-                <a:ea typeface="Microsoft JhengHei" panose="020B0604030504040204" pitchFamily="34" charset="-120"/>
-              </a:rPr>
-              <a:t>)</a:t>
-            </a:r>
-            <a:endParaRPr lang="vi-VN" sz="4267" b="1" dirty="0">
+              <a:t> )</a:t>
+            </a:r>
+            <a:endParaRPr lang="vi-VN" sz="3200" b="1" dirty="0">
               <a:solidFill>
                 <a:srgbClr val="000066"/>
               </a:solidFill>
@@ -5674,7 +5499,7 @@
         <p:spPr>
           <a:xfrm>
             <a:off x="0" y="5253203"/>
-            <a:ext cx="12192000" cy="748988"/>
+            <a:ext cx="12192000" cy="584775"/>
           </a:xfrm>
           <a:prstGeom prst="rect">
             <a:avLst/>
@@ -5689,54 +5514,39 @@
           <a:p>
             <a:pPr algn="ctr"/>
             <a:r>
-              <a:rPr lang="en-US" sz="4267" b="1" dirty="0">
+              <a:rPr lang="en-US" sz="3200" b="1" dirty="0">
                 <a:solidFill>
                   <a:srgbClr val="000066"/>
                 </a:solidFill>
-                <a:effectLst/>
                 <a:latin typeface="Microsoft JhengHei" panose="020B0604030504040204" pitchFamily="34" charset="-120"/>
                 <a:ea typeface="Microsoft JhengHei" panose="020B0604030504040204" pitchFamily="34" charset="-120"/>
               </a:rPr>
               <a:t>( </a:t>
             </a:r>
             <a:r>
-              <a:rPr lang="zh-CN" altLang="en-US" sz="4267" b="1" dirty="0" smtClean="0">
+              <a:rPr lang="zh-CN" altLang="en-US" sz="3200" b="1" dirty="0">
                 <a:solidFill>
                   <a:srgbClr val="000066"/>
                 </a:solidFill>
-                <a:effectLst/>
                 <a:latin typeface="Microsoft JhengHei" panose="020B0604030504040204" pitchFamily="34" charset="-120"/>
                 <a:ea typeface="Microsoft JhengHei" panose="020B0604030504040204" pitchFamily="34" charset="-120"/>
               </a:rPr>
-              <a:t>正</a:t>
-            </a:r>
-            <a:r>
-              <a:rPr lang="en-US" sz="4267" b="1" dirty="0" smtClean="0">
+              <a:t>正歌</a:t>
+            </a:r>
+            <a:r>
+              <a:rPr lang="en-US" sz="3200" b="1" dirty="0">
                 <a:solidFill>
                   <a:srgbClr val="000066"/>
                 </a:solidFill>
-                <a:effectLst/>
                 <a:latin typeface="Microsoft JhengHei" panose="020B0604030504040204" pitchFamily="34" charset="-120"/>
                 <a:ea typeface="Microsoft JhengHei" panose="020B0604030504040204" pitchFamily="34" charset="-120"/>
               </a:rPr>
-              <a:t> </a:t>
-            </a:r>
-            <a:r>
-              <a:rPr lang="en-US" sz="4267" b="1" dirty="0">
-                <a:solidFill>
-                  <a:srgbClr val="000066"/>
-                </a:solidFill>
-                <a:effectLst/>
-                <a:latin typeface="Microsoft JhengHei" panose="020B0604030504040204" pitchFamily="34" charset="-120"/>
-                <a:ea typeface="Microsoft JhengHei" panose="020B0604030504040204" pitchFamily="34" charset="-120"/>
-              </a:rPr>
-              <a:t>)</a:t>
-            </a:r>
-            <a:endParaRPr lang="vi-VN" sz="4267" b="1" dirty="0">
+              <a:t> )</a:t>
+            </a:r>
+            <a:endParaRPr lang="vi-VN" sz="3200" b="1" dirty="0">
               <a:solidFill>
                 <a:srgbClr val="000066"/>
               </a:solidFill>
-              <a:effectLst/>
               <a:ea typeface="Microsoft JhengHei" panose="020B0604030504040204" pitchFamily="34" charset="-120"/>
             </a:endParaRPr>
           </a:p>
@@ -6030,7 +5840,7 @@
         <p:spPr>
           <a:xfrm>
             <a:off x="0" y="5253203"/>
-            <a:ext cx="12192000" cy="748988"/>
+            <a:ext cx="12192000" cy="584775"/>
           </a:xfrm>
           <a:prstGeom prst="rect">
             <a:avLst/>
@@ -6045,54 +5855,39 @@
           <a:p>
             <a:pPr algn="ctr"/>
             <a:r>
-              <a:rPr lang="en-US" sz="4267" b="1" dirty="0">
+              <a:rPr lang="en-US" sz="3200" b="1" dirty="0">
                 <a:solidFill>
                   <a:srgbClr val="000066"/>
                 </a:solidFill>
-                <a:effectLst/>
                 <a:latin typeface="Microsoft JhengHei" panose="020B0604030504040204" pitchFamily="34" charset="-120"/>
                 <a:ea typeface="Microsoft JhengHei" panose="020B0604030504040204" pitchFamily="34" charset="-120"/>
               </a:rPr>
               <a:t>( </a:t>
             </a:r>
             <a:r>
-              <a:rPr lang="zh-CN" altLang="en-US" sz="4267" b="1" dirty="0" smtClean="0">
+              <a:rPr lang="zh-CN" altLang="en-US" sz="3200" b="1" dirty="0">
                 <a:solidFill>
                   <a:srgbClr val="000066"/>
                 </a:solidFill>
-                <a:effectLst/>
                 <a:latin typeface="Microsoft JhengHei" panose="020B0604030504040204" pitchFamily="34" charset="-120"/>
                 <a:ea typeface="Microsoft JhengHei" panose="020B0604030504040204" pitchFamily="34" charset="-120"/>
               </a:rPr>
-              <a:t>正</a:t>
-            </a:r>
-            <a:r>
-              <a:rPr lang="en-US" sz="4267" b="1" dirty="0" smtClean="0">
+              <a:t>正歌</a:t>
+            </a:r>
+            <a:r>
+              <a:rPr lang="en-US" sz="3200" b="1" dirty="0">
                 <a:solidFill>
                   <a:srgbClr val="000066"/>
                 </a:solidFill>
-                <a:effectLst/>
                 <a:latin typeface="Microsoft JhengHei" panose="020B0604030504040204" pitchFamily="34" charset="-120"/>
                 <a:ea typeface="Microsoft JhengHei" panose="020B0604030504040204" pitchFamily="34" charset="-120"/>
               </a:rPr>
-              <a:t> </a:t>
-            </a:r>
-            <a:r>
-              <a:rPr lang="en-US" sz="4267" b="1" dirty="0">
-                <a:solidFill>
-                  <a:srgbClr val="000066"/>
-                </a:solidFill>
-                <a:effectLst/>
-                <a:latin typeface="Microsoft JhengHei" panose="020B0604030504040204" pitchFamily="34" charset="-120"/>
-                <a:ea typeface="Microsoft JhengHei" panose="020B0604030504040204" pitchFamily="34" charset="-120"/>
-              </a:rPr>
-              <a:t>)</a:t>
-            </a:r>
-            <a:endParaRPr lang="vi-VN" sz="4267" b="1" dirty="0">
+              <a:t> )</a:t>
+            </a:r>
+            <a:endParaRPr lang="vi-VN" sz="3200" b="1" dirty="0">
               <a:solidFill>
                 <a:srgbClr val="000066"/>
               </a:solidFill>
-              <a:effectLst/>
               <a:ea typeface="Microsoft JhengHei" panose="020B0604030504040204" pitchFamily="34" charset="-120"/>
             </a:endParaRPr>
           </a:p>
@@ -6366,7 +6161,7 @@
         <p:spPr>
           <a:xfrm>
             <a:off x="0" y="5253203"/>
-            <a:ext cx="12192000" cy="748988"/>
+            <a:ext cx="12192000" cy="584775"/>
           </a:xfrm>
           <a:prstGeom prst="rect">
             <a:avLst/>
@@ -6381,54 +6176,39 @@
           <a:p>
             <a:pPr algn="ctr"/>
             <a:r>
-              <a:rPr lang="en-US" sz="4267" b="1" dirty="0">
+              <a:rPr lang="en-US" sz="3200" b="1" dirty="0">
                 <a:solidFill>
                   <a:srgbClr val="000066"/>
                 </a:solidFill>
-                <a:effectLst/>
                 <a:latin typeface="Microsoft JhengHei" panose="020B0604030504040204" pitchFamily="34" charset="-120"/>
                 <a:ea typeface="Microsoft JhengHei" panose="020B0604030504040204" pitchFamily="34" charset="-120"/>
               </a:rPr>
               <a:t>( </a:t>
             </a:r>
             <a:r>
-              <a:rPr lang="zh-CN" altLang="en-US" sz="4267" b="1" dirty="0" smtClean="0">
+              <a:rPr lang="zh-CN" altLang="en-US" sz="3200" b="1" dirty="0">
                 <a:solidFill>
                   <a:srgbClr val="000066"/>
                 </a:solidFill>
-                <a:effectLst/>
                 <a:latin typeface="Microsoft JhengHei" panose="020B0604030504040204" pitchFamily="34" charset="-120"/>
                 <a:ea typeface="Microsoft JhengHei" panose="020B0604030504040204" pitchFamily="34" charset="-120"/>
               </a:rPr>
-              <a:t>正</a:t>
-            </a:r>
-            <a:r>
-              <a:rPr lang="en-US" sz="4267" b="1" dirty="0" smtClean="0">
+              <a:t>正歌</a:t>
+            </a:r>
+            <a:r>
+              <a:rPr lang="en-US" sz="3200" b="1" dirty="0">
                 <a:solidFill>
                   <a:srgbClr val="000066"/>
                 </a:solidFill>
-                <a:effectLst/>
                 <a:latin typeface="Microsoft JhengHei" panose="020B0604030504040204" pitchFamily="34" charset="-120"/>
                 <a:ea typeface="Microsoft JhengHei" panose="020B0604030504040204" pitchFamily="34" charset="-120"/>
               </a:rPr>
-              <a:t> </a:t>
-            </a:r>
-            <a:r>
-              <a:rPr lang="en-US" sz="4267" b="1" dirty="0">
-                <a:solidFill>
-                  <a:srgbClr val="000066"/>
-                </a:solidFill>
-                <a:effectLst/>
-                <a:latin typeface="Microsoft JhengHei" panose="020B0604030504040204" pitchFamily="34" charset="-120"/>
-                <a:ea typeface="Microsoft JhengHei" panose="020B0604030504040204" pitchFamily="34" charset="-120"/>
-              </a:rPr>
-              <a:t>)</a:t>
-            </a:r>
-            <a:endParaRPr lang="vi-VN" sz="4267" b="1" dirty="0">
+              <a:t> )</a:t>
+            </a:r>
+            <a:endParaRPr lang="vi-VN" sz="3200" b="1" dirty="0">
               <a:solidFill>
                 <a:srgbClr val="000066"/>
               </a:solidFill>
-              <a:effectLst/>
               <a:ea typeface="Microsoft JhengHei" panose="020B0604030504040204" pitchFamily="34" charset="-120"/>
             </a:endParaRPr>
           </a:p>
@@ -6722,7 +6502,7 @@
         <p:spPr>
           <a:xfrm>
             <a:off x="0" y="5253203"/>
-            <a:ext cx="12192000" cy="748988"/>
+            <a:ext cx="12192000" cy="584775"/>
           </a:xfrm>
           <a:prstGeom prst="rect">
             <a:avLst/>
@@ -6737,54 +6517,39 @@
           <a:p>
             <a:pPr algn="ctr"/>
             <a:r>
-              <a:rPr lang="en-US" sz="4267" b="1" dirty="0">
+              <a:rPr lang="en-US" sz="3200" b="1" dirty="0">
                 <a:solidFill>
                   <a:srgbClr val="000066"/>
                 </a:solidFill>
-                <a:effectLst/>
                 <a:latin typeface="Microsoft JhengHei" panose="020B0604030504040204" pitchFamily="34" charset="-120"/>
                 <a:ea typeface="Microsoft JhengHei" panose="020B0604030504040204" pitchFamily="34" charset="-120"/>
               </a:rPr>
               <a:t>( </a:t>
             </a:r>
             <a:r>
-              <a:rPr lang="zh-CN" altLang="en-US" sz="4267" b="1" dirty="0" smtClean="0">
+              <a:rPr lang="zh-CN" altLang="en-US" sz="3200" b="1" dirty="0">
                 <a:solidFill>
                   <a:srgbClr val="000066"/>
                 </a:solidFill>
-                <a:effectLst/>
                 <a:latin typeface="Microsoft JhengHei" panose="020B0604030504040204" pitchFamily="34" charset="-120"/>
                 <a:ea typeface="Microsoft JhengHei" panose="020B0604030504040204" pitchFamily="34" charset="-120"/>
               </a:rPr>
-              <a:t>正</a:t>
-            </a:r>
-            <a:r>
-              <a:rPr lang="en-US" sz="4267" b="1" dirty="0" smtClean="0">
+              <a:t>正歌</a:t>
+            </a:r>
+            <a:r>
+              <a:rPr lang="en-US" sz="3200" b="1" dirty="0">
                 <a:solidFill>
                   <a:srgbClr val="000066"/>
                 </a:solidFill>
-                <a:effectLst/>
                 <a:latin typeface="Microsoft JhengHei" panose="020B0604030504040204" pitchFamily="34" charset="-120"/>
                 <a:ea typeface="Microsoft JhengHei" panose="020B0604030504040204" pitchFamily="34" charset="-120"/>
               </a:rPr>
-              <a:t> </a:t>
-            </a:r>
-            <a:r>
-              <a:rPr lang="en-US" sz="4267" b="1" dirty="0">
-                <a:solidFill>
-                  <a:srgbClr val="000066"/>
-                </a:solidFill>
-                <a:effectLst/>
-                <a:latin typeface="Microsoft JhengHei" panose="020B0604030504040204" pitchFamily="34" charset="-120"/>
-                <a:ea typeface="Microsoft JhengHei" panose="020B0604030504040204" pitchFamily="34" charset="-120"/>
-              </a:rPr>
-              <a:t>)</a:t>
-            </a:r>
-            <a:endParaRPr lang="vi-VN" sz="4267" b="1" dirty="0">
+              <a:t> )</a:t>
+            </a:r>
+            <a:endParaRPr lang="vi-VN" sz="3200" b="1" dirty="0">
               <a:solidFill>
                 <a:srgbClr val="000066"/>
               </a:solidFill>
-              <a:effectLst/>
               <a:ea typeface="Microsoft JhengHei" panose="020B0604030504040204" pitchFamily="34" charset="-120"/>
             </a:endParaRPr>
           </a:p>
@@ -6853,20 +6618,10 @@
                 <a:latin typeface="微軟正黑體" pitchFamily="34" charset="-120"/>
                 <a:ea typeface="微軟正黑體" pitchFamily="34" charset="-120"/>
               </a:rPr>
-              <a:t>祂愛</a:t>
-            </a:r>
-            <a:r>
-              <a:rPr lang="zh-TW" altLang="en-US" sz="6400" b="1" dirty="0" smtClean="0">
-                <a:solidFill>
-                  <a:srgbClr val="000066"/>
-                </a:solidFill>
-                <a:latin typeface="微軟正黑體" pitchFamily="34" charset="-120"/>
-                <a:ea typeface="微軟正黑體" pitchFamily="34" charset="-120"/>
-              </a:rPr>
-              <a:t>你</a:t>
-            </a:r>
-            <a:r>
-              <a:rPr lang="vi-VN" altLang="zh-TW" sz="6400" b="1" dirty="0" smtClean="0">
+              <a:t>祂愛你</a:t>
+            </a:r>
+            <a:r>
+              <a:rPr lang="vi-VN" altLang="zh-TW" sz="6400" b="1" dirty="0">
                 <a:solidFill>
                   <a:srgbClr val="000066"/>
                 </a:solidFill>
@@ -6876,24 +6631,14 @@
               <a:t>  </a:t>
             </a:r>
             <a:r>
-              <a:rPr lang="zh-TW" altLang="en-US" sz="6400" b="1" dirty="0" smtClean="0">
+              <a:rPr lang="zh-TW" altLang="en-US" sz="6400" b="1" dirty="0">
                 <a:solidFill>
                   <a:srgbClr val="000066"/>
                 </a:solidFill>
                 <a:latin typeface="微軟正黑體" pitchFamily="34" charset="-120"/>
                 <a:ea typeface="微軟正黑體" pitchFamily="34" charset="-120"/>
               </a:rPr>
-              <a:t>使</a:t>
-            </a:r>
-            <a:r>
-              <a:rPr lang="zh-TW" altLang="en-US" sz="6400" b="1" dirty="0">
-                <a:solidFill>
-                  <a:srgbClr val="000066"/>
-                </a:solidFill>
-                <a:latin typeface="微軟正黑體" pitchFamily="34" charset="-120"/>
-                <a:ea typeface="微軟正黑體" pitchFamily="34" charset="-120"/>
-              </a:rPr>
-              <a:t>你能痊癒</a:t>
+              <a:t>使你能痊癒</a:t>
             </a:r>
             <a:endParaRPr lang="en-US" altLang="zh-CN" sz="6400" b="1" dirty="0">
               <a:solidFill>
@@ -7098,7 +6843,7 @@
         <p:spPr>
           <a:xfrm>
             <a:off x="0" y="5253203"/>
-            <a:ext cx="12192000" cy="748988"/>
+            <a:ext cx="12192000" cy="584775"/>
           </a:xfrm>
           <a:prstGeom prst="rect">
             <a:avLst/>
@@ -7113,54 +6858,39 @@
           <a:p>
             <a:pPr algn="ctr"/>
             <a:r>
-              <a:rPr lang="en-US" sz="4267" b="1" dirty="0">
+              <a:rPr lang="en-US" sz="3200" b="1" dirty="0">
                 <a:solidFill>
                   <a:srgbClr val="000066"/>
                 </a:solidFill>
-                <a:effectLst/>
                 <a:latin typeface="Microsoft JhengHei" panose="020B0604030504040204" pitchFamily="34" charset="-120"/>
                 <a:ea typeface="Microsoft JhengHei" panose="020B0604030504040204" pitchFamily="34" charset="-120"/>
               </a:rPr>
               <a:t>( </a:t>
             </a:r>
             <a:r>
-              <a:rPr lang="zh-CN" altLang="en-US" sz="4267" b="1" dirty="0" smtClean="0">
+              <a:rPr lang="zh-CN" altLang="en-US" sz="3200" b="1" dirty="0">
                 <a:solidFill>
                   <a:srgbClr val="000066"/>
                 </a:solidFill>
-                <a:effectLst/>
                 <a:latin typeface="Microsoft JhengHei" panose="020B0604030504040204" pitchFamily="34" charset="-120"/>
                 <a:ea typeface="Microsoft JhengHei" panose="020B0604030504040204" pitchFamily="34" charset="-120"/>
               </a:rPr>
-              <a:t>正</a:t>
-            </a:r>
-            <a:r>
-              <a:rPr lang="en-US" sz="4267" b="1" dirty="0" smtClean="0">
+              <a:t>正歌</a:t>
+            </a:r>
+            <a:r>
+              <a:rPr lang="en-US" sz="3200" b="1" dirty="0">
                 <a:solidFill>
                   <a:srgbClr val="000066"/>
                 </a:solidFill>
-                <a:effectLst/>
                 <a:latin typeface="Microsoft JhengHei" panose="020B0604030504040204" pitchFamily="34" charset="-120"/>
                 <a:ea typeface="Microsoft JhengHei" panose="020B0604030504040204" pitchFamily="34" charset="-120"/>
               </a:rPr>
-              <a:t> </a:t>
-            </a:r>
-            <a:r>
-              <a:rPr lang="en-US" sz="4267" b="1" dirty="0">
-                <a:solidFill>
-                  <a:srgbClr val="000066"/>
-                </a:solidFill>
-                <a:effectLst/>
-                <a:latin typeface="Microsoft JhengHei" panose="020B0604030504040204" pitchFamily="34" charset="-120"/>
-                <a:ea typeface="Microsoft JhengHei" panose="020B0604030504040204" pitchFamily="34" charset="-120"/>
-              </a:rPr>
-              <a:t>)</a:t>
-            </a:r>
-            <a:endParaRPr lang="vi-VN" sz="4267" b="1" dirty="0">
+              <a:t> )</a:t>
+            </a:r>
+            <a:endParaRPr lang="vi-VN" sz="3200" b="1" dirty="0">
               <a:solidFill>
                 <a:srgbClr val="000066"/>
               </a:solidFill>
-              <a:effectLst/>
               <a:ea typeface="Microsoft JhengHei" panose="020B0604030504040204" pitchFamily="34" charset="-120"/>
             </a:endParaRPr>
           </a:p>
@@ -7454,7 +7184,7 @@
         <p:spPr>
           <a:xfrm>
             <a:off x="0" y="5253203"/>
-            <a:ext cx="12192000" cy="748988"/>
+            <a:ext cx="12192000" cy="584775"/>
           </a:xfrm>
           <a:prstGeom prst="rect">
             <a:avLst/>
@@ -7469,54 +7199,39 @@
           <a:p>
             <a:pPr algn="ctr"/>
             <a:r>
-              <a:rPr lang="en-US" sz="4267" b="1" dirty="0">
+              <a:rPr lang="en-US" sz="3200" b="1" dirty="0">
                 <a:solidFill>
                   <a:srgbClr val="000066"/>
                 </a:solidFill>
-                <a:effectLst/>
                 <a:latin typeface="Microsoft JhengHei" panose="020B0604030504040204" pitchFamily="34" charset="-120"/>
                 <a:ea typeface="Microsoft JhengHei" panose="020B0604030504040204" pitchFamily="34" charset="-120"/>
               </a:rPr>
               <a:t>( </a:t>
             </a:r>
             <a:r>
-              <a:rPr lang="zh-CN" altLang="en-US" sz="4267" b="1" dirty="0" smtClean="0">
+              <a:rPr lang="zh-CN" altLang="en-US" sz="3200" b="1" dirty="0">
                 <a:solidFill>
                   <a:srgbClr val="000066"/>
                 </a:solidFill>
-                <a:effectLst/>
                 <a:latin typeface="Microsoft JhengHei" panose="020B0604030504040204" pitchFamily="34" charset="-120"/>
                 <a:ea typeface="Microsoft JhengHei" panose="020B0604030504040204" pitchFamily="34" charset="-120"/>
               </a:rPr>
-              <a:t>正</a:t>
-            </a:r>
-            <a:r>
-              <a:rPr lang="en-US" sz="4267" b="1" dirty="0" smtClean="0">
+              <a:t>正歌</a:t>
+            </a:r>
+            <a:r>
+              <a:rPr lang="en-US" sz="3200" b="1" dirty="0">
                 <a:solidFill>
                   <a:srgbClr val="000066"/>
                 </a:solidFill>
-                <a:effectLst/>
                 <a:latin typeface="Microsoft JhengHei" panose="020B0604030504040204" pitchFamily="34" charset="-120"/>
                 <a:ea typeface="Microsoft JhengHei" panose="020B0604030504040204" pitchFamily="34" charset="-120"/>
               </a:rPr>
-              <a:t> </a:t>
-            </a:r>
-            <a:r>
-              <a:rPr lang="en-US" sz="4267" b="1" dirty="0">
-                <a:solidFill>
-                  <a:srgbClr val="000066"/>
-                </a:solidFill>
-                <a:effectLst/>
-                <a:latin typeface="Microsoft JhengHei" panose="020B0604030504040204" pitchFamily="34" charset="-120"/>
-                <a:ea typeface="Microsoft JhengHei" panose="020B0604030504040204" pitchFamily="34" charset="-120"/>
-              </a:rPr>
-              <a:t>)</a:t>
-            </a:r>
-            <a:endParaRPr lang="vi-VN" sz="4267" b="1" dirty="0">
+              <a:t> )</a:t>
+            </a:r>
+            <a:endParaRPr lang="vi-VN" sz="3200" b="1" dirty="0">
               <a:solidFill>
                 <a:srgbClr val="000066"/>
               </a:solidFill>
-              <a:effectLst/>
               <a:ea typeface="Microsoft JhengHei" panose="020B0604030504040204" pitchFamily="34" charset="-120"/>
             </a:endParaRPr>
           </a:p>
@@ -7790,7 +7505,7 @@
         <p:spPr>
           <a:xfrm>
             <a:off x="0" y="5253203"/>
-            <a:ext cx="12192000" cy="748988"/>
+            <a:ext cx="12192000" cy="584775"/>
           </a:xfrm>
           <a:prstGeom prst="rect">
             <a:avLst/>
@@ -7805,54 +7520,39 @@
           <a:p>
             <a:pPr algn="ctr"/>
             <a:r>
-              <a:rPr lang="en-US" sz="4267" b="1" dirty="0">
+              <a:rPr lang="en-US" sz="3200" b="1" dirty="0">
                 <a:solidFill>
                   <a:srgbClr val="000066"/>
                 </a:solidFill>
-                <a:effectLst/>
                 <a:latin typeface="Microsoft JhengHei" panose="020B0604030504040204" pitchFamily="34" charset="-120"/>
                 <a:ea typeface="Microsoft JhengHei" panose="020B0604030504040204" pitchFamily="34" charset="-120"/>
               </a:rPr>
               <a:t>( </a:t>
             </a:r>
             <a:r>
-              <a:rPr lang="zh-CN" altLang="en-US" sz="4267" b="1" dirty="0" smtClean="0">
+              <a:rPr lang="zh-CN" altLang="en-US" sz="3200" b="1" dirty="0">
                 <a:solidFill>
                   <a:srgbClr val="000066"/>
                 </a:solidFill>
-                <a:effectLst/>
                 <a:latin typeface="Microsoft JhengHei" panose="020B0604030504040204" pitchFamily="34" charset="-120"/>
                 <a:ea typeface="Microsoft JhengHei" panose="020B0604030504040204" pitchFamily="34" charset="-120"/>
               </a:rPr>
-              <a:t>正</a:t>
-            </a:r>
-            <a:r>
-              <a:rPr lang="en-US" sz="4267" b="1" dirty="0" smtClean="0">
+              <a:t>正歌</a:t>
+            </a:r>
+            <a:r>
+              <a:rPr lang="en-US" sz="3200" b="1" dirty="0">
                 <a:solidFill>
                   <a:srgbClr val="000066"/>
                 </a:solidFill>
-                <a:effectLst/>
                 <a:latin typeface="Microsoft JhengHei" panose="020B0604030504040204" pitchFamily="34" charset="-120"/>
                 <a:ea typeface="Microsoft JhengHei" panose="020B0604030504040204" pitchFamily="34" charset="-120"/>
               </a:rPr>
-              <a:t> </a:t>
-            </a:r>
-            <a:r>
-              <a:rPr lang="en-US" sz="4267" b="1" dirty="0">
-                <a:solidFill>
-                  <a:srgbClr val="000066"/>
-                </a:solidFill>
-                <a:effectLst/>
-                <a:latin typeface="Microsoft JhengHei" panose="020B0604030504040204" pitchFamily="34" charset="-120"/>
-                <a:ea typeface="Microsoft JhengHei" panose="020B0604030504040204" pitchFamily="34" charset="-120"/>
-              </a:rPr>
-              <a:t>)</a:t>
-            </a:r>
-            <a:endParaRPr lang="vi-VN" sz="4267" b="1" dirty="0">
+              <a:t> )</a:t>
+            </a:r>
+            <a:endParaRPr lang="vi-VN" sz="3200" b="1" dirty="0">
               <a:solidFill>
                 <a:srgbClr val="000066"/>
               </a:solidFill>
-              <a:effectLst/>
               <a:ea typeface="Microsoft JhengHei" panose="020B0604030504040204" pitchFamily="34" charset="-120"/>
             </a:endParaRPr>
           </a:p>

</xml_diff>